<commit_message>
fix(submission): say lab captures, not real, on slide 4
</commit_message>
<xml_diff>
--- a/submission/seva-innovation-challenge-2026/NyaySaakshya_Seva_Innovation_Challenge_2026.pptx
+++ b/submission/seva-innovation-challenge-2026/NyaySaakshya_Seva_Innovation_Challenge_2026.pptx
@@ -545,7 +545,7 @@
           <a:lstStyle/>
           <a:p>
             <a:r>
-              <a:t>Basis. Internal validation record: 98 controlled captures (10 real Postfix and Dovecot sessions, 6 OpenSSL handshakes, 82 crafted by in-project generators); 1,521 automated tests; identical results on repeat runs for 98 of 98 captures. No real-world or third-party traffic has been evaluated and no false-positive or false-negative rates are claimed. The security gaps listed are the known blockers for any pilot. Timeline items are proposals, not commitments. No hosting or implementation cost is stated because none has been verified.</a:t>
+              <a:t>Basis. Internal validation record: 98 controlled captures (10 sessions from real Postfix and Dovecot software run in a lab, 6 OpenSSL handshakes, 82 crafted by in-project generators; no real-world traffic); 1,521 automated tests; identical results on repeat runs for 98 of 98 captures. No real-world or third-party traffic has been evaluated and no false-positive or false-negative rates are claimed. The security gaps listed are the known blockers for any pilot. Timeline items are proposals, not commitments. No hosting or implementation cost is stated because none has been verified.</a:t>
             </a:r>
           </a:p>
         </p:txBody>
@@ -6850,7 +6850,7 @@
                 </a:solidFill>
                 <a:latin typeface="Nirmala UI"/>
               </a:rPr>
-              <a:t>98 controlled captures: 10 real Postfix and Dovecot, 6 OpenSSL handshakes, 82 crafted in-project</a:t>
+              <a:t>98 controlled lab captures: 10 from Postfix and Dovecot software in a lab, 6 OpenSSL handshakes, 82 crafted in-project</a:t>
             </a:r>
           </a:p>
           <a:p>
@@ -6924,7 +6924,7 @@
                 </a:solidFill>
                 <a:latin typeface="Nirmala UI"/>
               </a:rPr>
-              <a:t>Lab validation only: no real-world accuracy benchmark.</a:t>
+              <a:t>Lab validation only: no real-world traffic and no accuracy benchmark.</a:t>
             </a:r>
           </a:p>
         </p:txBody>

</xml_diff>

<commit_message>
feat(submission): align deck with official applicant guide and implemented architecture
</commit_message>
<xml_diff>
--- a/submission/seva-innovation-challenge-2026/NyaySaakshya_Seva_Innovation_Challenge_2026.pptx
+++ b/submission/seva-innovation-challenge-2026/NyaySaakshya_Seva_Innovation_Challenge_2026.pptx
@@ -459,7 +459,7 @@
           <a:lstStyle/>
           <a:p>
             <a:r>
-              <a:t>Sources. Evidence states and abstention are properties of the prototype, shown here from a real local run on a synthetic capture. NIST SP 800-52 Rev. 2 (Guidelines for the Selection, Configuration, and Use of TLS Implementations). Comparison basis, documentation read 15 Oct 2026: Wireshark user guide (Expert Information) and TLS wiki; Zeek SMTP::Info (a tls true/false field); NetworkMiner product page (extracts files, emails and credentials from PCAPs; not designed to decrypt). No benchmark was run against these tools and no speed or accuracy comparison is made.</a:t>
+              <a:t>Sources. Architecture as implemented (backend pipeline module): upload, SHA-256 and validation, read-only TShark dissection, session reconstruction with STARTTLS/TLS state, evidence extraction, 16 single-session and 3 cross-session rules, posture engine (score or withheld), then JSON/HTML/PDF reports rendered from the stored assessment. An optional anomaly lane is off by default and cannot change a finding, band, score or coverage. Evidence states and abstention are shown from a real local run on a synthetic capture. NIST SP 800-52 Rev. 2 (Guidelines for the Selection, Configuration, and Use of TLS Implementations). Comparison basis, documentation read 15 Oct 2026: Wireshark user guide (Expert Information) and TLS wiki; Zeek SMTP::Info (a tls true/false field); NetworkMiner product page (extracts files, emails and credentials from PCAPs; not designed to decrypt). No benchmark was run against these tools and no speed or accuracy comparison is made.</a:t>
             </a:r>
           </a:p>
         </p:txBody>
@@ -2993,7 +2993,7 @@
           <a:p>
             <a:pPr marL="0" indent="0">
               <a:spcAft>
-                <a:spcPts val="400"/>
+                <a:spcPts val="300"/>
               </a:spcAft>
               <a:buNone/>
             </a:pPr>
@@ -3010,7 +3010,7 @@
           <a:p>
             <a:pPr marL="0" indent="0">
               <a:spcAft>
-                <a:spcPts val="400"/>
+                <a:spcPts val="300"/>
               </a:spcAft>
               <a:buNone/>
             </a:pPr>
@@ -3021,13 +3021,13 @@
                 </a:solidFill>
                 <a:latin typeface="Nirmala UI"/>
               </a:rPr>
-              <a:t>A conclusion the evidence cannot support is a weak foundation for any cyber-fraud case built on it.</a:t>
-            </a:r>
-          </a:p>
-          <a:p>
-            <a:pPr marL="0" indent="0">
-              <a:spcAft>
-                <a:spcPts val="400"/>
+              <a:t>A conclusion the evidence cannot support is a weak foundation for a case.</a:t>
+            </a:r>
+          </a:p>
+          <a:p>
+            <a:pPr marL="0" indent="0">
+              <a:spcAft>
+                <a:spcPts val="300"/>
               </a:spcAft>
               <a:buNone/>
             </a:pPr>
@@ -3044,7 +3044,7 @@
           <a:p>
             <a:pPr marL="0" indent="0">
               <a:spcAft>
-                <a:spcPts val="400"/>
+                <a:spcPts val="300"/>
               </a:spcAft>
               <a:buNone/>
             </a:pPr>
@@ -3055,13 +3055,13 @@
                 </a:solidFill>
                 <a:latin typeface="Nirmala UI"/>
               </a:rPr>
-              <a:t>Cyber-cell and forensic investigators, and the supervisors who must defend a finding. Proposed first users: a Maharashtra cyber cell or forensic lab. No partner has agreed yet.</a:t>
-            </a:r>
-          </a:p>
-          <a:p>
-            <a:pPr marL="0" indent="0">
-              <a:spcAft>
-                <a:spcPts val="400"/>
+              <a:t>Cyber-cell and forensic investigators and their supervisors. Proposed first users: a Maharashtra cyber cell or forensic lab; no partner has agreed.</a:t>
+            </a:r>
+          </a:p>
+          <a:p>
+            <a:pPr marL="0" indent="0">
+              <a:spcAft>
+                <a:spcPts val="300"/>
               </a:spcAft>
               <a:buNone/>
             </a:pPr>
@@ -3078,7 +3078,7 @@
           <a:p>
             <a:pPr marL="0" indent="0">
               <a:spcAft>
-                <a:spcPts val="400"/>
+                <a:spcPts val="300"/>
               </a:spcAft>
               <a:buNone/>
             </a:pPr>
@@ -3090,6 +3090,40 @@
                 <a:latin typeface="Nirmala UI"/>
               </a:rPr>
               <a:t>Packet tools show packets. Deciding what is safe to conclude is manual and hard to repeat.</a:t>
+            </a:r>
+          </a:p>
+          <a:p>
+            <a:pPr marL="0" indent="0">
+              <a:spcAft>
+                <a:spcPts val="300"/>
+              </a:spcAft>
+              <a:buNone/>
+            </a:pPr>
+            <a:r>
+              <a:rPr sz="1150" b="1" i="0">
+                <a:solidFill>
+                  <a:srgbClr val="F28C28"/>
+                </a:solidFill>
+                <a:latin typeface="Nirmala UI"/>
+              </a:rPr>
+              <a:t>Not yet known</a:t>
+            </a:r>
+          </a:p>
+          <a:p>
+            <a:pPr marL="0" indent="0">
+              <a:spcAft>
+                <a:spcPts val="300"/>
+              </a:spcAft>
+              <a:buNone/>
+            </a:pPr>
+            <a:r>
+              <a:rPr sz="1000" b="0" i="0">
+                <a:solidFill>
+                  <a:srgbClr val="FFFFFF"/>
+                </a:solidFill>
+                <a:latin typeface="Nirmala UI"/>
+              </a:rPr>
+              <a:t>How often investigators meet such captures. None consulted yet.</a:t>
             </a:r>
           </a:p>
         </p:txBody>
@@ -3419,7 +3453,7 @@
         <p:spPr>
           <a:xfrm>
             <a:off x="457200" y="1152144"/>
-            <a:ext cx="1252728" cy="658368"/>
+            <a:ext cx="1252728" cy="768096"/>
           </a:xfrm>
           <a:prstGeom prst="roundRect">
             <a:avLst>
@@ -3467,7 +3501,7 @@
         <p:spPr>
           <a:xfrm>
             <a:off x="530352" y="1188720"/>
-            <a:ext cx="1106424" cy="228600"/>
+            <a:ext cx="1106424" cy="201168"/>
           </a:xfrm>
           <a:prstGeom prst="rect">
             <a:avLst/>
@@ -3507,7 +3541,7 @@
         <p:spPr>
           <a:xfrm>
             <a:off x="530352" y="1408176"/>
-            <a:ext cx="1106424" cy="384048"/>
+            <a:ext cx="1106424" cy="502920"/>
           </a:xfrm>
           <a:prstGeom prst="rect">
             <a:avLst/>
@@ -3533,7 +3567,7 @@
                 </a:solidFill>
                 <a:latin typeface="Nirmala UI"/>
               </a:rPr>
-              <a:t>Saved PCAP or PCAPNG; SHA-256 recorded</a:t>
+              <a:t>Web upload of a PCAP or PCAPNG; SHA-256 recorded</a:t>
             </a:r>
           </a:p>
         </p:txBody>
@@ -3546,7 +3580,7 @@
         </p:nvSpPr>
         <p:spPr>
           <a:xfrm>
-            <a:off x="1709928" y="1335024"/>
+            <a:off x="1709928" y="1371600"/>
             <a:ext cx="142646" cy="274320"/>
           </a:xfrm>
           <a:prstGeom prst="rect">
@@ -3587,7 +3621,7 @@
         <p:spPr>
           <a:xfrm>
             <a:off x="1852574" y="1152144"/>
-            <a:ext cx="1252728" cy="658368"/>
+            <a:ext cx="1252728" cy="768096"/>
           </a:xfrm>
           <a:prstGeom prst="roundRect">
             <a:avLst>
@@ -3635,7 +3669,7 @@
         <p:spPr>
           <a:xfrm>
             <a:off x="1925726" y="1188720"/>
-            <a:ext cx="1106424" cy="228600"/>
+            <a:ext cx="1106424" cy="201168"/>
           </a:xfrm>
           <a:prstGeom prst="rect">
             <a:avLst/>
@@ -3661,7 +3695,7 @@
                 </a:solidFill>
                 <a:latin typeface="Nirmala UI"/>
               </a:rPr>
-              <a:t>Analysis</a:t>
+              <a:t>TShark parse</a:t>
             </a:r>
           </a:p>
         </p:txBody>
@@ -3675,7 +3709,7 @@
         <p:spPr>
           <a:xfrm>
             <a:off x="1925726" y="1408176"/>
-            <a:ext cx="1106424" cy="384048"/>
+            <a:ext cx="1106424" cy="502920"/>
           </a:xfrm>
           <a:prstGeom prst="rect">
             <a:avLst/>
@@ -3701,7 +3735,7 @@
                 </a:solidFill>
                 <a:latin typeface="Nirmala UI"/>
               </a:rPr>
-              <a:t>TShark parses; sessions rebuilt</a:t>
+              <a:t>Read-only. No live capture, no decryption</a:t>
             </a:r>
           </a:p>
         </p:txBody>
@@ -3714,7 +3748,7 @@
         </p:nvSpPr>
         <p:spPr>
           <a:xfrm>
-            <a:off x="3105302" y="1335024"/>
+            <a:off x="3105302" y="1371600"/>
             <a:ext cx="142646" cy="274320"/>
           </a:xfrm>
           <a:prstGeom prst="rect">
@@ -3755,7 +3789,7 @@
         <p:spPr>
           <a:xfrm>
             <a:off x="3247948" y="1152144"/>
-            <a:ext cx="1252728" cy="658368"/>
+            <a:ext cx="1252728" cy="768096"/>
           </a:xfrm>
           <a:prstGeom prst="roundRect">
             <a:avLst>
@@ -3803,7 +3837,7 @@
         <p:spPr>
           <a:xfrm>
             <a:off x="3321100" y="1188720"/>
-            <a:ext cx="1106424" cy="228600"/>
+            <a:ext cx="1106424" cy="201168"/>
           </a:xfrm>
           <a:prstGeom prst="rect">
             <a:avLst/>
@@ -3829,7 +3863,7 @@
                 </a:solidFill>
                 <a:latin typeface="Nirmala UI"/>
               </a:rPr>
-              <a:t>Evidence</a:t>
+              <a:t>Sessions</a:t>
             </a:r>
           </a:p>
         </p:txBody>
@@ -3843,7 +3877,7 @@
         <p:spPr>
           <a:xfrm>
             <a:off x="3321100" y="1408176"/>
-            <a:ext cx="1106424" cy="384048"/>
+            <a:ext cx="1106424" cy="502920"/>
           </a:xfrm>
           <a:prstGeom prst="rect">
             <a:avLst/>
@@ -3869,7 +3903,7 @@
                 </a:solidFill>
                 <a:latin typeface="Nirmala UI"/>
               </a:rPr>
-              <a:t>Every fact gets a state</a:t>
+              <a:t>Sessions rebuilt; every fact gets an evidence state</a:t>
             </a:r>
           </a:p>
         </p:txBody>
@@ -3882,7 +3916,7 @@
         </p:nvSpPr>
         <p:spPr>
           <a:xfrm>
-            <a:off x="4500676" y="1335024"/>
+            <a:off x="4500676" y="1371600"/>
             <a:ext cx="142646" cy="274320"/>
           </a:xfrm>
           <a:prstGeom prst="rect">
@@ -3923,7 +3957,7 @@
         <p:spPr>
           <a:xfrm>
             <a:off x="4643323" y="1152144"/>
-            <a:ext cx="1252728" cy="658368"/>
+            <a:ext cx="1252728" cy="768096"/>
           </a:xfrm>
           <a:prstGeom prst="roundRect">
             <a:avLst>
@@ -3971,7 +4005,7 @@
         <p:spPr>
           <a:xfrm>
             <a:off x="4716475" y="1188720"/>
-            <a:ext cx="1106424" cy="228600"/>
+            <a:ext cx="1106424" cy="201168"/>
           </a:xfrm>
           <a:prstGeom prst="rect">
             <a:avLst/>
@@ -3997,7 +4031,7 @@
                 </a:solidFill>
                 <a:latin typeface="Nirmala UI"/>
               </a:rPr>
-              <a:t>Finding</a:t>
+              <a:t>Rules</a:t>
             </a:r>
           </a:p>
         </p:txBody>
@@ -4011,7 +4045,7 @@
         <p:spPr>
           <a:xfrm>
             <a:off x="4716475" y="1408176"/>
-            <a:ext cx="1106424" cy="384048"/>
+            <a:ext cx="1106424" cy="502920"/>
           </a:xfrm>
           <a:prstGeom prst="rect">
             <a:avLst/>
@@ -4037,7 +4071,7 @@
                 </a:solidFill>
                 <a:latin typeface="Nirmala UI"/>
               </a:rPr>
-              <a:t>Rule, standard and frame cited</a:t>
+              <a:t>19 versioned rules cited to RFC or NIST. No AI in verdicts</a:t>
             </a:r>
           </a:p>
         </p:txBody>
@@ -4050,7 +4084,7 @@
         </p:nvSpPr>
         <p:spPr>
           <a:xfrm>
-            <a:off x="5896051" y="1335024"/>
+            <a:off x="5896051" y="1371600"/>
             <a:ext cx="142646" cy="274320"/>
           </a:xfrm>
           <a:prstGeom prst="rect">
@@ -4091,7 +4125,7 @@
         <p:spPr>
           <a:xfrm>
             <a:off x="6038697" y="1152144"/>
-            <a:ext cx="1252728" cy="658368"/>
+            <a:ext cx="1252728" cy="768096"/>
           </a:xfrm>
           <a:prstGeom prst="roundRect">
             <a:avLst>
@@ -4139,7 +4173,7 @@
         <p:spPr>
           <a:xfrm>
             <a:off x="6111849" y="1188720"/>
-            <a:ext cx="1106424" cy="228600"/>
+            <a:ext cx="1106424" cy="201168"/>
           </a:xfrm>
           <a:prstGeom prst="rect">
             <a:avLst/>
@@ -4179,7 +4213,7 @@
         <p:spPr>
           <a:xfrm>
             <a:off x="6111849" y="1408176"/>
-            <a:ext cx="1106424" cy="384048"/>
+            <a:ext cx="1106424" cy="502920"/>
           </a:xfrm>
           <a:prstGeom prst="rect">
             <a:avLst/>
@@ -4205,7 +4239,7 @@
                 </a:solidFill>
                 <a:latin typeface="Nirmala UI"/>
               </a:rPr>
-              <a:t>A score, or none</a:t>
+              <a:t>A score, or Not scored when evidence is thin</a:t>
             </a:r>
           </a:p>
         </p:txBody>
@@ -4218,7 +4252,7 @@
         </p:nvSpPr>
         <p:spPr>
           <a:xfrm>
-            <a:off x="7291425" y="1335024"/>
+            <a:off x="7291425" y="1371600"/>
             <a:ext cx="142646" cy="274320"/>
           </a:xfrm>
           <a:prstGeom prst="rect">
@@ -4259,7 +4293,7 @@
         <p:spPr>
           <a:xfrm>
             <a:off x="7434071" y="1152144"/>
-            <a:ext cx="1252728" cy="658368"/>
+            <a:ext cx="1252728" cy="768096"/>
           </a:xfrm>
           <a:prstGeom prst="roundRect">
             <a:avLst>
@@ -4307,7 +4341,7 @@
         <p:spPr>
           <a:xfrm>
             <a:off x="7507223" y="1188720"/>
-            <a:ext cx="1106424" cy="228600"/>
+            <a:ext cx="1106424" cy="201168"/>
           </a:xfrm>
           <a:prstGeom prst="rect">
             <a:avLst/>
@@ -4333,7 +4367,7 @@
                 </a:solidFill>
                 <a:latin typeface="Nirmala UI"/>
               </a:rPr>
-              <a:t>Report</a:t>
+              <a:t>Reports</a:t>
             </a:r>
           </a:p>
         </p:txBody>
@@ -4347,7 +4381,7 @@
         <p:spPr>
           <a:xfrm>
             <a:off x="7507223" y="1408176"/>
-            <a:ext cx="1106424" cy="384048"/>
+            <a:ext cx="1106424" cy="502920"/>
           </a:xfrm>
           <a:prstGeom prst="rect">
             <a:avLst/>
@@ -4373,7 +4407,7 @@
                 </a:solidFill>
                 <a:latin typeface="Nirmala UI"/>
               </a:rPr>
-              <a:t>JSON, HTML and PDF</a:t>
+              <a:t>JSON, HTML, PDF with packet citations</a:t>
             </a:r>
           </a:p>
         </p:txBody>
@@ -4386,7 +4420,7 @@
         </p:nvSpPr>
         <p:spPr>
           <a:xfrm>
-            <a:off x="457200" y="1901952"/>
+            <a:off x="457200" y="2011680"/>
             <a:ext cx="3931920" cy="237744"/>
           </a:xfrm>
           <a:prstGeom prst="rect">
@@ -4426,7 +4460,7 @@
         </p:nvSpPr>
         <p:spPr>
           <a:xfrm>
-            <a:off x="457200" y="2194560"/>
+            <a:off x="457200" y="2286000"/>
             <a:ext cx="1920240" cy="475488"/>
           </a:xfrm>
           <a:prstGeom prst="roundRect">
@@ -4474,7 +4508,7 @@
         </p:nvSpPr>
         <p:spPr>
           <a:xfrm>
-            <a:off x="548640" y="2231136"/>
+            <a:off x="548640" y="2322576"/>
             <a:ext cx="1783080" cy="182880"/>
           </a:xfrm>
           <a:prstGeom prst="rect">
@@ -4514,7 +4548,7 @@
         </p:nvSpPr>
         <p:spPr>
           <a:xfrm>
-            <a:off x="548640" y="2423160"/>
+            <a:off x="548640" y="2514600"/>
             <a:ext cx="1783080" cy="256032"/>
           </a:xfrm>
           <a:prstGeom prst="rect">
@@ -4554,7 +4588,7 @@
         </p:nvSpPr>
         <p:spPr>
           <a:xfrm>
-            <a:off x="2468880" y="2194560"/>
+            <a:off x="2468880" y="2286000"/>
             <a:ext cx="1920240" cy="475488"/>
           </a:xfrm>
           <a:prstGeom prst="roundRect">
@@ -4602,7 +4636,7 @@
         </p:nvSpPr>
         <p:spPr>
           <a:xfrm>
-            <a:off x="2560320" y="2231136"/>
+            <a:off x="2560320" y="2322576"/>
             <a:ext cx="1783080" cy="182880"/>
           </a:xfrm>
           <a:prstGeom prst="rect">
@@ -4642,7 +4676,7 @@
         </p:nvSpPr>
         <p:spPr>
           <a:xfrm>
-            <a:off x="2560320" y="2423160"/>
+            <a:off x="2560320" y="2514600"/>
             <a:ext cx="1783080" cy="256032"/>
           </a:xfrm>
           <a:prstGeom prst="rect">
@@ -4682,7 +4716,7 @@
         </p:nvSpPr>
         <p:spPr>
           <a:xfrm>
-            <a:off x="457200" y="2743200"/>
+            <a:off x="457200" y="2834640"/>
             <a:ext cx="1920240" cy="475488"/>
           </a:xfrm>
           <a:prstGeom prst="roundRect">
@@ -4730,7 +4764,7 @@
         </p:nvSpPr>
         <p:spPr>
           <a:xfrm>
-            <a:off x="548640" y="2779776"/>
+            <a:off x="548640" y="2871216"/>
             <a:ext cx="1783080" cy="182880"/>
           </a:xfrm>
           <a:prstGeom prst="rect">
@@ -4770,7 +4804,7 @@
         </p:nvSpPr>
         <p:spPr>
           <a:xfrm>
-            <a:off x="548640" y="2971800"/>
+            <a:off x="548640" y="3063240"/>
             <a:ext cx="1783080" cy="256032"/>
           </a:xfrm>
           <a:prstGeom prst="rect">
@@ -4810,7 +4844,7 @@
         </p:nvSpPr>
         <p:spPr>
           <a:xfrm>
-            <a:off x="2468880" y="2743200"/>
+            <a:off x="2468880" y="2834640"/>
             <a:ext cx="1920240" cy="475488"/>
           </a:xfrm>
           <a:prstGeom prst="roundRect">
@@ -4858,7 +4892,7 @@
         </p:nvSpPr>
         <p:spPr>
           <a:xfrm>
-            <a:off x="2560320" y="2779776"/>
+            <a:off x="2560320" y="2871216"/>
             <a:ext cx="1783080" cy="182880"/>
           </a:xfrm>
           <a:prstGeom prst="rect">
@@ -4898,7 +4932,7 @@
         </p:nvSpPr>
         <p:spPr>
           <a:xfrm>
-            <a:off x="2560320" y="2971800"/>
+            <a:off x="2560320" y="3063240"/>
             <a:ext cx="1783080" cy="256032"/>
           </a:xfrm>
           <a:prstGeom prst="rect">
@@ -4938,7 +4972,7 @@
         </p:nvSpPr>
         <p:spPr>
           <a:xfrm>
-            <a:off x="457200" y="3291839"/>
+            <a:off x="457200" y="3383280"/>
             <a:ext cx="1920240" cy="475488"/>
           </a:xfrm>
           <a:prstGeom prst="roundRect">
@@ -4986,7 +5020,7 @@
         </p:nvSpPr>
         <p:spPr>
           <a:xfrm>
-            <a:off x="548640" y="3328415"/>
+            <a:off x="548640" y="3419856"/>
             <a:ext cx="1783080" cy="182880"/>
           </a:xfrm>
           <a:prstGeom prst="rect">
@@ -5026,7 +5060,7 @@
         </p:nvSpPr>
         <p:spPr>
           <a:xfrm>
-            <a:off x="548640" y="3520439"/>
+            <a:off x="548640" y="3611880"/>
             <a:ext cx="1783080" cy="256032"/>
           </a:xfrm>
           <a:prstGeom prst="rect">
@@ -5066,7 +5100,7 @@
         </p:nvSpPr>
         <p:spPr>
           <a:xfrm>
-            <a:off x="2468880" y="3291839"/>
+            <a:off x="2468880" y="3383280"/>
             <a:ext cx="1920240" cy="475488"/>
           </a:xfrm>
           <a:prstGeom prst="roundRect">
@@ -5114,7 +5148,7 @@
         </p:nvSpPr>
         <p:spPr>
           <a:xfrm>
-            <a:off x="2560320" y="3328415"/>
+            <a:off x="2560320" y="3419856"/>
             <a:ext cx="1783080" cy="182880"/>
           </a:xfrm>
           <a:prstGeom prst="rect">
@@ -5154,7 +5188,7 @@
         </p:nvSpPr>
         <p:spPr>
           <a:xfrm>
-            <a:off x="2560320" y="3520439"/>
+            <a:off x="2560320" y="3611880"/>
             <a:ext cx="1783080" cy="256032"/>
           </a:xfrm>
           <a:prstGeom prst="rect">
@@ -5194,7 +5228,7 @@
         </p:nvSpPr>
         <p:spPr>
           <a:xfrm>
-            <a:off x="457200" y="3840480"/>
+            <a:off x="457200" y="3904487"/>
             <a:ext cx="3931920" cy="182880"/>
           </a:xfrm>
           <a:prstGeom prst="rect">
@@ -5261,7 +5295,7 @@
         </p:nvSpPr>
         <p:spPr>
           <a:xfrm>
-            <a:off x="4709160" y="1901952"/>
+            <a:off x="4709160" y="2011680"/>
             <a:ext cx="3977639" cy="237744"/>
           </a:xfrm>
           <a:prstGeom prst="rect">
@@ -5301,7 +5335,7 @@
         </p:nvSpPr>
         <p:spPr>
           <a:xfrm>
-            <a:off x="4709160" y="2194560"/>
+            <a:off x="4709160" y="2286000"/>
             <a:ext cx="3977639" cy="365760"/>
           </a:xfrm>
           <a:prstGeom prst="roundRect">
@@ -5349,7 +5383,7 @@
         </p:nvSpPr>
         <p:spPr>
           <a:xfrm>
-            <a:off x="4818888" y="2194560"/>
+            <a:off x="4818888" y="2286000"/>
             <a:ext cx="640080" cy="365760"/>
           </a:xfrm>
           <a:prstGeom prst="rect">
@@ -5389,7 +5423,7 @@
         </p:nvSpPr>
         <p:spPr>
           <a:xfrm>
-            <a:off x="5440680" y="2194560"/>
+            <a:off x="5440680" y="2286000"/>
             <a:ext cx="3154680" cy="365760"/>
           </a:xfrm>
           <a:prstGeom prst="rect">
@@ -5429,7 +5463,7 @@
         </p:nvSpPr>
         <p:spPr>
           <a:xfrm>
-            <a:off x="4709160" y="2615184"/>
+            <a:off x="4709160" y="2706624"/>
             <a:ext cx="3977639" cy="457200"/>
           </a:xfrm>
           <a:prstGeom prst="roundRect">
@@ -5477,7 +5511,7 @@
         </p:nvSpPr>
         <p:spPr>
           <a:xfrm>
-            <a:off x="4818888" y="2615184"/>
+            <a:off x="4818888" y="2706624"/>
             <a:ext cx="640080" cy="457200"/>
           </a:xfrm>
           <a:prstGeom prst="rect">
@@ -5517,7 +5551,7 @@
         </p:nvSpPr>
         <p:spPr>
           <a:xfrm>
-            <a:off x="5440680" y="2615184"/>
+            <a:off x="5440680" y="2706624"/>
             <a:ext cx="3154680" cy="457200"/>
           </a:xfrm>
           <a:prstGeom prst="rect">
@@ -5557,7 +5591,7 @@
         </p:nvSpPr>
         <p:spPr>
           <a:xfrm>
-            <a:off x="4709160" y="3127248"/>
+            <a:off x="4709160" y="3218688"/>
             <a:ext cx="3977639" cy="365760"/>
           </a:xfrm>
           <a:prstGeom prst="roundRect">
@@ -5605,7 +5639,7 @@
         </p:nvSpPr>
         <p:spPr>
           <a:xfrm>
-            <a:off x="4818888" y="3127248"/>
+            <a:off x="4818888" y="3218688"/>
             <a:ext cx="640080" cy="365760"/>
           </a:xfrm>
           <a:prstGeom prst="rect">
@@ -5645,7 +5679,7 @@
         </p:nvSpPr>
         <p:spPr>
           <a:xfrm>
-            <a:off x="5440680" y="3127248"/>
+            <a:off x="5440680" y="3218688"/>
             <a:ext cx="3154680" cy="365760"/>
           </a:xfrm>
           <a:prstGeom prst="rect">
@@ -5685,7 +5719,7 @@
         </p:nvSpPr>
         <p:spPr>
           <a:xfrm>
-            <a:off x="4709160" y="3547872"/>
+            <a:off x="4709160" y="3639312"/>
             <a:ext cx="3977639" cy="365760"/>
           </a:xfrm>
           <a:prstGeom prst="roundRect">
@@ -5733,7 +5767,7 @@
         </p:nvSpPr>
         <p:spPr>
           <a:xfrm>
-            <a:off x="4818888" y="3547872"/>
+            <a:off x="4818888" y="3639312"/>
             <a:ext cx="640080" cy="365760"/>
           </a:xfrm>
           <a:prstGeom prst="rect">
@@ -5773,7 +5807,7 @@
         </p:nvSpPr>
         <p:spPr>
           <a:xfrm>
-            <a:off x="5440680" y="3547872"/>
+            <a:off x="5440680" y="3639312"/>
             <a:ext cx="3154680" cy="365760"/>
           </a:xfrm>
           <a:prstGeom prst="rect">
@@ -5813,7 +5847,7 @@
         </p:nvSpPr>
         <p:spPr>
           <a:xfrm>
-            <a:off x="4709160" y="3968496"/>
+            <a:off x="4709160" y="4059936"/>
             <a:ext cx="3977639" cy="182880"/>
           </a:xfrm>
           <a:prstGeom prst="rect">
@@ -5853,8 +5887,8 @@
         </p:nvSpPr>
         <p:spPr>
           <a:xfrm>
-            <a:off x="457200" y="4206240"/>
-            <a:ext cx="4572000" cy="548640"/>
+            <a:off x="457200" y="4242816"/>
+            <a:ext cx="4572000" cy="530352"/>
           </a:xfrm>
           <a:prstGeom prst="roundRect">
             <a:avLst>
@@ -5901,8 +5935,8 @@
         </p:nvSpPr>
         <p:spPr>
           <a:xfrm>
-            <a:off x="594360" y="4206240"/>
-            <a:ext cx="4343400" cy="548640"/>
+            <a:off x="594360" y="4242816"/>
+            <a:ext cx="4343400" cy="530352"/>
           </a:xfrm>
           <a:prstGeom prst="rect">
             <a:avLst/>
@@ -5950,8 +5984,8 @@
         </p:nvSpPr>
         <p:spPr>
           <a:xfrm>
-            <a:off x="5138928" y="4206240"/>
-            <a:ext cx="3547872" cy="548640"/>
+            <a:off x="5138928" y="4242816"/>
+            <a:ext cx="3547872" cy="530352"/>
           </a:xfrm>
           <a:prstGeom prst="roundRect">
             <a:avLst>
@@ -5998,8 +6032,8 @@
         </p:nvSpPr>
         <p:spPr>
           <a:xfrm>
-            <a:off x="5257800" y="4206240"/>
-            <a:ext cx="3337560" cy="548640"/>
+            <a:off x="5257800" y="4242816"/>
+            <a:ext cx="3337560" cy="530352"/>
           </a:xfrm>
           <a:prstGeom prst="rect">
             <a:avLst/>
@@ -6884,7 +6918,7 @@
                 </a:solidFill>
                 <a:latin typeface="Nirmala UI"/>
               </a:rPr>
-              <a:t>Validation found and fixed cases where the engine over-read evidence</a:t>
+              <a:t>Failure found and fixed: on 44 cut-off streams the engine said "no TLS" 41 times; now once (an arguable case)</a:t>
             </a:r>
           </a:p>
         </p:txBody>
@@ -7406,7 +7440,7 @@
                 </a:solidFill>
                 <a:latin typeface="Nirmala UI"/>
               </a:rPr>
-              <a:t>Depends on security mentorship, a willing unit and that unit's legal approval for real captures. Costs not yet estimated.</a:t>
+              <a:t>Depends on security mentorship, a willing unit and its legal approval for real captures. Cost not priced; a technical pilot needs no cloud service or GPU.</a:t>
             </a:r>
           </a:p>
         </p:txBody>
@@ -7908,7 +7942,7 @@
         <p:spPr>
           <a:xfrm>
             <a:off x="3374136" y="1691640"/>
-            <a:ext cx="2395728" cy="384048"/>
+            <a:ext cx="2395728" cy="365760"/>
           </a:xfrm>
           <a:prstGeom prst="roundRect">
             <a:avLst>
@@ -7953,7 +7987,7 @@
         </p:nvSpPr>
         <p:spPr>
           <a:xfrm>
-            <a:off x="3429000" y="1755648"/>
+            <a:off x="3429000" y="1746504"/>
             <a:ext cx="256032" cy="256032"/>
           </a:xfrm>
           <a:prstGeom prst="ellipse">
@@ -7997,7 +8031,7 @@
         </p:nvSpPr>
         <p:spPr>
           <a:xfrm>
-            <a:off x="3429000" y="1755648"/>
+            <a:off x="3429000" y="1746504"/>
             <a:ext cx="256032" cy="256032"/>
           </a:xfrm>
           <a:prstGeom prst="rect">
@@ -8038,7 +8072,7 @@
         <p:spPr>
           <a:xfrm>
             <a:off x="3758183" y="1691640"/>
-            <a:ext cx="1965960" cy="384048"/>
+            <a:ext cx="1965960" cy="365760"/>
           </a:xfrm>
           <a:prstGeom prst="rect">
             <a:avLst/>
@@ -8058,7 +8092,7 @@
               <a:buNone/>
             </a:pPr>
             <a:r>
-              <a:rPr sz="950" b="0" i="0">
+              <a:rPr sz="900" b="0" i="0">
                 <a:solidFill>
                   <a:srgbClr val="2F3A56"/>
                 </a:solidFill>
@@ -8077,8 +8111,8 @@
         </p:nvSpPr>
         <p:spPr>
           <a:xfrm>
-            <a:off x="3374136" y="2148840"/>
-            <a:ext cx="2395728" cy="384048"/>
+            <a:off x="3374136" y="2112264"/>
+            <a:ext cx="2395728" cy="365760"/>
           </a:xfrm>
           <a:prstGeom prst="roundRect">
             <a:avLst>
@@ -8123,7 +8157,7 @@
         </p:nvSpPr>
         <p:spPr>
           <a:xfrm>
-            <a:off x="3429000" y="2212848"/>
+            <a:off x="3429000" y="2167128"/>
             <a:ext cx="256032" cy="256032"/>
           </a:xfrm>
           <a:prstGeom prst="ellipse">
@@ -8167,7 +8201,7 @@
         </p:nvSpPr>
         <p:spPr>
           <a:xfrm>
-            <a:off x="3429000" y="2212848"/>
+            <a:off x="3429000" y="2167128"/>
             <a:ext cx="256032" cy="256032"/>
           </a:xfrm>
           <a:prstGeom prst="rect">
@@ -8207,8 +8241,8 @@
         </p:nvSpPr>
         <p:spPr>
           <a:xfrm>
-            <a:off x="3758183" y="2148840"/>
-            <a:ext cx="1965960" cy="384048"/>
+            <a:off x="3758183" y="2112264"/>
+            <a:ext cx="1965960" cy="365760"/>
           </a:xfrm>
           <a:prstGeom prst="rect">
             <a:avLst/>
@@ -8228,13 +8262,13 @@
               <a:buNone/>
             </a:pPr>
             <a:r>
-              <a:rPr sz="950" b="0" i="0">
+              <a:rPr sz="900" b="0" i="0">
                 <a:solidFill>
                   <a:srgbClr val="2F3A56"/>
                 </a:solidFill>
                 <a:latin typeface="Nirmala UI"/>
               </a:rPr>
-              <a:t>One supervised unit</a:t>
+              <a:t>One supervised unit: a cyber cell or forensic lab</a:t>
             </a:r>
           </a:p>
         </p:txBody>
@@ -8247,8 +8281,8 @@
         </p:nvSpPr>
         <p:spPr>
           <a:xfrm>
-            <a:off x="3374136" y="2606040"/>
-            <a:ext cx="2395728" cy="384048"/>
+            <a:off x="3374136" y="2532888"/>
+            <a:ext cx="2395728" cy="365760"/>
           </a:xfrm>
           <a:prstGeom prst="roundRect">
             <a:avLst>
@@ -8293,7 +8327,7 @@
         </p:nvSpPr>
         <p:spPr>
           <a:xfrm>
-            <a:off x="3429000" y="2670048"/>
+            <a:off x="3429000" y="2587752"/>
             <a:ext cx="256032" cy="256032"/>
           </a:xfrm>
           <a:prstGeom prst="ellipse">
@@ -8337,7 +8371,7 @@
         </p:nvSpPr>
         <p:spPr>
           <a:xfrm>
-            <a:off x="3429000" y="2670048"/>
+            <a:off x="3429000" y="2587752"/>
             <a:ext cx="256032" cy="256032"/>
           </a:xfrm>
           <a:prstGeom prst="rect">
@@ -8377,8 +8411,8 @@
         </p:nvSpPr>
         <p:spPr>
           <a:xfrm>
-            <a:off x="3758183" y="2606040"/>
-            <a:ext cx="1965960" cy="384048"/>
+            <a:off x="3758183" y="2532888"/>
+            <a:ext cx="1965960" cy="365760"/>
           </a:xfrm>
           <a:prstGeom prst="rect">
             <a:avLst/>
@@ -8398,7 +8432,7 @@
               <a:buNone/>
             </a:pPr>
             <a:r>
-              <a:rPr sz="950" b="0" i="0">
+              <a:rPr sz="900" b="0" i="0">
                 <a:solidFill>
                   <a:srgbClr val="2F3A56"/>
                 </a:solidFill>
@@ -8417,8 +8451,8 @@
         </p:nvSpPr>
         <p:spPr>
           <a:xfrm>
-            <a:off x="3374136" y="3081528"/>
-            <a:ext cx="2395728" cy="457200"/>
+            <a:off x="3374136" y="2971800"/>
+            <a:ext cx="2395728" cy="566928"/>
           </a:xfrm>
           <a:prstGeom prst="rect">
             <a:avLst/>
@@ -8444,7 +8478,7 @@
                 </a:solidFill>
                 <a:latin typeface="Nirmala UI"/>
               </a:rPr>
-              <a:t>Each unit would run it locally, so captures stay in its own environment. A design intention, not built or validated.</a:t>
+              <a:t>Likely owner: Home Department (police cyber cells); no office approached yet. Each unit would run it locally: a design intention, not built or validated.</a:t>
             </a:r>
           </a:p>
         </p:txBody>
@@ -8670,8 +8704,8 @@
         </p:nvSpPr>
         <p:spPr>
           <a:xfrm>
-            <a:off x="6163056" y="3063240"/>
-            <a:ext cx="2395728" cy="365760"/>
+            <a:off x="6163056" y="2816352"/>
+            <a:ext cx="2395728" cy="731520"/>
           </a:xfrm>
           <a:prstGeom prst="rect">
             <a:avLst/>
@@ -8697,7 +8731,7 @@
                 </a:solidFill>
                 <a:latin typeface="Nirmala UI"/>
               </a:rPr>
-              <a:t>Baselines come from the pilot. No targets are claimed yet.</a:t>
+              <a:t>Before: current practice, measured in the pilot. After: with NyaySaakshya. No targets claimed. The existing cost it targets is analyst time, to be measured.</a:t>
             </a:r>
           </a:p>
         </p:txBody>
@@ -9357,6 +9391,23 @@
               <a:t>Individual application (team size 1)</a:t>
             </a:r>
           </a:p>
+          <a:p>
+            <a:pPr marL="0" indent="0">
+              <a:spcAft>
+                <a:spcPts val="300"/>
+              </a:spcAft>
+              <a:buNone/>
+            </a:pPr>
+            <a:r>
+              <a:rPr sz="900" b="0" i="0">
+                <a:solidFill>
+                  <a:srgbClr val="C9D2EC"/>
+                </a:solidFill>
+                <a:latin typeface="Nirmala UI"/>
+              </a:rPr>
+              <a:t>No other team member, mentor, partner or funder is named.</a:t>
+            </a:r>
+          </a:p>
         </p:txBody>
       </p:sp>
       <p:sp>
@@ -9368,7 +9419,7 @@
         <p:spPr>
           <a:xfrm>
             <a:off x="457200" y="2450592"/>
-            <a:ext cx="3429000" cy="1828800"/>
+            <a:ext cx="3429000" cy="2011680"/>
           </a:xfrm>
           <a:prstGeom prst="roundRect">
             <a:avLst>
@@ -9504,13 +9555,30 @@
               <a:buNone/>
             </a:pPr>
             <a:r>
-              <a:rPr sz="900" b="0" i="0">
-                <a:solidFill>
-                  <a:srgbClr val="C9D2EC"/>
-                </a:solidFill>
-                <a:latin typeface="Nirmala UI"/>
-              </a:rPr>
-              <a:t>Individual application: no other team member, mentor, partner or funder is named.</a:t>
+              <a:rPr sz="1050" b="1" i="0">
+                <a:solidFill>
+                  <a:srgbClr val="F28C28"/>
+                </a:solidFill>
+                <a:latin typeface="Nirmala UI"/>
+              </a:rPr>
+              <a:t>Demonstrable now</a:t>
+            </a:r>
+          </a:p>
+          <a:p>
+            <a:pPr marL="0" indent="0">
+              <a:spcAft>
+                <a:spcPts val="500"/>
+              </a:spcAft>
+              <a:buNone/>
+            </a:pPr>
+            <a:r>
+              <a:rPr sz="1000" b="0" i="0">
+                <a:solidFill>
+                  <a:srgbClr val="FFFFFF"/>
+                </a:solidFill>
+                <a:latin typeface="Nirmala UI"/>
+              </a:rPr>
+              <a:t>A local demo on synthetic captures: a supported finding, a withheld score and a report export.</a:t>
             </a:r>
           </a:p>
         </p:txBody>

</xml_diff>

<commit_message>
fix(submission): align deck wording with reviewed portal answers
</commit_message>
<xml_diff>
--- a/submission/seva-innovation-challenge-2026/NyaySaakshya_Seva_Innovation_Challenge_2026.pptx
+++ b/submission/seva-innovation-challenge-2026/NyaySaakshya_Seva_Innovation_Challenge_2026.pptx
@@ -5887,8 +5887,8 @@
         </p:nvSpPr>
         <p:spPr>
           <a:xfrm>
-            <a:off x="457200" y="4242816"/>
-            <a:ext cx="4572000" cy="530352"/>
+            <a:off x="457200" y="4224528"/>
+            <a:ext cx="4572000" cy="566928"/>
           </a:xfrm>
           <a:prstGeom prst="roundRect">
             <a:avLst>
@@ -5935,8 +5935,8 @@
         </p:nvSpPr>
         <p:spPr>
           <a:xfrm>
-            <a:off x="594360" y="4242816"/>
-            <a:ext cx="4343400" cy="530352"/>
+            <a:off x="594360" y="4224528"/>
+            <a:ext cx="4343400" cy="566928"/>
           </a:xfrm>
           <a:prstGeom prst="rect">
             <a:avLst/>
@@ -5984,8 +5984,8 @@
         </p:nvSpPr>
         <p:spPr>
           <a:xfrm>
-            <a:off x="5138928" y="4242816"/>
-            <a:ext cx="3547872" cy="530352"/>
+            <a:off x="5138928" y="4224528"/>
+            <a:ext cx="3547872" cy="566928"/>
           </a:xfrm>
           <a:prstGeom prst="roundRect">
             <a:avLst>
@@ -6032,8 +6032,8 @@
         </p:nvSpPr>
         <p:spPr>
           <a:xfrm>
-            <a:off x="5257800" y="4242816"/>
-            <a:ext cx="3337560" cy="530352"/>
+            <a:off x="5257800" y="4224528"/>
+            <a:ext cx="3337560" cy="566928"/>
           </a:xfrm>
           <a:prstGeom prst="rect">
             <a:avLst/>
@@ -6068,7 +6068,7 @@
                 </a:solidFill>
                 <a:latin typeface="Nirmala UI"/>
               </a:rPr>
-              <a:t>Wireshark, Zeek and NetworkMiner expose packets and fields. Their documentation, as we read it, has no per-fact evidence states. A design strength, not a claim of uniqueness.</a:t>
+              <a:t>Wireshark, Zeek and NetworkMiner expose packets and fields. The documentation we reviewed does not describe per-fact evidence states (not proof they lack them). A design strength, not uniqueness.</a:t>
             </a:r>
           </a:p>
         </p:txBody>
@@ -6901,7 +6901,7 @@
                 </a:solidFill>
                 <a:latin typeface="Nirmala UI"/>
               </a:rPr>
-              <a:t>Same capture and software give the same result (98 of 98)</a:t>
+              <a:t>Repeat runs gave the same result (98 of 98 captures)</a:t>
             </a:r>
           </a:p>
           <a:p>
@@ -7374,7 +7374,7 @@
                 </a:solidFill>
                 <a:latin typeface="Nirmala UI"/>
               </a:rPr>
-              <a:t>technical pilot on synthetic or consented captures</a:t>
+              <a:t>technical pilot on synthetic captures</a:t>
             </a:r>
           </a:p>
           <a:p>
@@ -7400,7 +7400,7 @@
                 </a:solidFill>
                 <a:latin typeface="Nirmala UI"/>
               </a:rPr>
-              <a:t>supervised single-unit pilot, only if a department agrees</a:t>
+              <a:t>supervised single-unit pilot, only if a department agrees; real case data only once authorised and prerequisites are met</a:t>
             </a:r>
           </a:p>
         </p:txBody>
@@ -7806,7 +7806,7 @@
                 </a:solidFill>
                 <a:latin typeface="Nirmala UI"/>
               </a:rPr>
-              <a:t>Findings can be re-checked: the same capture gives the same result</a:t>
+              <a:t>Findings can be re-checked: repeat runs gave the same result</a:t>
             </a:r>
           </a:p>
           <a:p>

</xml_diff>